<commit_message>
Docs + GTM refresh to GA-4-complete state; VALIDATED_RELEASE for v0.9.1-pilot-rc2
- README: 117 tests; new 'Validated evidence' section (live happy path, IaC gateway ENFORCE, fail-closed proofs, 8 live findings fixed)
- VALIDATED_RELEASE.md: rc2 release block + GA-4 clean-account validation table
- PRODUCTION-PLAN: A8 formal release DONE
- GTM: customer + leadership deck proof slides rebuilt on captured evidence; regulatory doc evidence rows updated; Depth-Evidence points to production validation evidence; decks/docx regenerated from generators
</commit_message>
<xml_diff>
--- a/docs/Housing-AgentCore-Customer.pptx
+++ b/docs/Housing-AgentCore-Customer.pptx
@@ -1127,7 +1127,7 @@
           <a:p>
             <a:r>
               <a:rPr lang="en-US" dirty="0"/>
-              <a:t>Reproducible and enforced. The income-vs-AMI engine is deterministic and transparent, so a housing specialist can defend each determination at an informal hearing.</a:t>
+              <a:t>Reproducible and enforced. Two clean-account validation runs are captured in the repo (evidence/): the full governed pipeline SUCCEEDED live on real services, and the Cedar authorization gateway reached CREATE_COMPLETE in ENFORCE as pure infrastructure-as-code. The income-vs-AMI engine is deterministic and transparent, so a housing specialist can defend each determination at an informal hearing.</a:t>
             </a:r>
             <a:endParaRPr lang="en-US" dirty="0"/>
           </a:p>
@@ -2424,7 +2424,7 @@
                 <a:ea typeface="Calibri" pitchFamily="34" charset="-122"/>
                 <a:cs typeface="Calibri" pitchFamily="34" charset="-120"/>
               </a:rPr>
-              <a:t>Walk your housing-program, privacy, and security teams through the architecture and the live 30-check proof.</a:t>
+              <a:t>Walk your housing-program, privacy, and security teams through the architecture and the captured validation evidence.</a:t>
             </a:r>
             <a:endParaRPr lang="en-US" sz="1230" dirty="0"/>
           </a:p>
@@ -8946,7 +8946,7 @@
                 <a:ea typeface="Cambria" pitchFamily="34" charset="-122"/>
                 <a:cs typeface="Cambria" pitchFamily="34" charset="-120"/>
               </a:rPr>
-              <a:t>30/30</a:t>
+              <a:t>117/117</a:t>
             </a:r>
             <a:endParaRPr lang="en-US" sz="3000" dirty="0"/>
           </a:p>
@@ -8988,7 +8988,7 @@
                 <a:ea typeface="Calibri" pitchFamily="34" charset="-122"/>
                 <a:cs typeface="Calibri" pitchFamily="34" charset="-120"/>
               </a:rPr>
-              <a:t>governance checks pass, live</a:t>
+              <a:t>automated tests green in CI</a:t>
             </a:r>
             <a:endParaRPr lang="en-US" sz="1150" dirty="0"/>
           </a:p>
@@ -9061,7 +9061,7 @@
                 <a:ea typeface="Cambria" pitchFamily="34" charset="-122"/>
                 <a:cs typeface="Cambria" pitchFamily="34" charset="-120"/>
               </a:rPr>
-              <a:t>AMI-based</a:t>
+              <a:t>End-to-end</a:t>
             </a:r>
             <a:endParaRPr lang="en-US" sz="3000" dirty="0"/>
           </a:p>
@@ -9103,7 +9103,7 @@
                 <a:ea typeface="Calibri" pitchFamily="34" charset="-122"/>
                 <a:cs typeface="Calibri" pitchFamily="34" charset="-120"/>
               </a:rPr>
-              <a:t>eligibility computed deterministically</a:t>
+              <a:t>governed pipeline proven live on AWS</a:t>
             </a:r>
             <a:endParaRPr lang="en-US" sz="1150" dirty="0"/>
           </a:p>
@@ -9291,7 +9291,7 @@
                 <a:ea typeface="Calibri" pitchFamily="34" charset="-122"/>
                 <a:cs typeface="Calibri" pitchFamily="34" charset="-120"/>
               </a:rPr>
-              <a:t>Demonstrated live, in enforcement mode:</a:t>
+              <a:t>Validated live in your deployment path (AWS CDK), enforcement on — evidence captured in the repo:</a:t>
             </a:r>
             <a:endParaRPr lang="en-US" sz="1350" dirty="0"/>
           </a:p>
@@ -9399,7 +9399,7 @@
                 <a:ea typeface="Calibri" pitchFamily="34" charset="-122"/>
                 <a:cs typeface="Calibri" pitchFamily="34" charset="-120"/>
               </a:rPr>
-              <a:t>A real, de-identified determination notice drafted by the model</a:t>
+              <a:t>The full governed workflow ran end-to-end live — intake to committed determination</a:t>
             </a:r>
             <a:endParaRPr lang="en-US" sz="1250" dirty="0"/>
           </a:p>
@@ -9507,7 +9507,7 @@
                 <a:ea typeface="Calibri" pitchFamily="34" charset="-122"/>
                 <a:cs typeface="Calibri" pitchFamily="34" charset="-120"/>
               </a:rPr>
-              <a:t>PII (name, SSN, address) removed before the model — fail-closed</a:t>
+              <a:t>PII removed before the model — fail-closed, and cryptographically proven downstream</a:t>
             </a:r>
             <a:endParaRPr lang="en-US" sz="1250" dirty="0"/>
           </a:p>
@@ -9615,7 +9615,7 @@
                 <a:ea typeface="Calibri" pitchFamily="34" charset="-122"/>
                 <a:cs typeface="Calibri" pitchFamily="34" charset="-120"/>
               </a:rPr>
-              <a:t>A live, authoritative HUD income-limit lookup, stamped with provenance</a:t>
+              <a:t>A live, authoritative HUD income-limit lookup with a verified provenance signature</a:t>
             </a:r>
             <a:endParaRPr lang="en-US" sz="1250" dirty="0"/>
           </a:p>
@@ -9831,7 +9831,7 @@
                 <a:ea typeface="Calibri" pitchFamily="34" charset="-122"/>
                 <a:cs typeface="Calibri" pitchFamily="34" charset="-120"/>
               </a:rPr>
-              <a:t>A different specialist required to approve; approvals are single-use</a:t>
+              <a:t>A different specialist approves; the approval is bound to the exact case content and finalizes exactly once</a:t>
             </a:r>
             <a:endParaRPr lang="en-US" sz="1250" dirty="0"/>
           </a:p>
@@ -9939,7 +9939,7 @@
                 <a:ea typeface="Calibri" pitchFamily="34" charset="-122"/>
                 <a:cs typeface="Calibri" pitchFamily="34" charset="-120"/>
               </a:rPr>
-              <a:t>Tamper-proof audit written for each step; duplicates rejected</a:t>
+              <a:t>Tamper-evident (hash-chained) audit of every step; the authorization gateway deploys as code, in ENFORCE</a:t>
             </a:r>
             <a:endParaRPr lang="en-US" sz="1250" dirty="0"/>
           </a:p>

</xml_diff>